<commit_message>
Corrige a raiz do GitHub Pages e fixa os links reais do projeto
A raiz do site servia o README renderizado pelo Jekyll em vez da aplicacao.
Como o link entregue a avaliacao e a raiz do dominio, ela precisa levar
direto ao painel.

- index.html na raiz: redireciona para dashboard/ com fallback visivel
- .nojekyll: desliga o processamento do Jekyll e serve os arquivos como estao
- README, deck e notas do slide: placeholders trocados pelas URLs reais
- .gitignore: ignora o PDF gerado na conferencia visual do deck
</commit_message>
<xml_diff>
--- a/EC_Sprint_2_1TSCO_EvidenciasConstrucao_PULSO_VitalAnalytics.pptx
+++ b/EC_Sprint_2_1TSCO_EvidenciasConstrucao_PULSO_VitalAnalytics.pptx
@@ -13421,7 +13421,7 @@
                 <a:ea typeface="Calibri" pitchFamily="34" charset="-122"/>
                 <a:cs typeface="Calibri" pitchFamily="34" charset="-120"/>
               </a:rPr>
-              <a:t>Repositório público:   github.com/&lt;usuario&gt;/pulso-vital-analytics</a:t>
+              <a:t>Repositório público:   github.com/nelsondiniz-p/pulso-vital-analytics</a:t>
             </a:r>
             <a:endParaRPr lang="en-US" sz="1200" dirty="0"/>
           </a:p>
@@ -20252,7 +20252,21 @@
                 <a:ea typeface="Calibri" pitchFamily="34" charset="-122"/>
                 <a:cs typeface="Calibri" pitchFamily="34" charset="-120"/>
               </a:rPr>
-              <a:t>Aplicação navegável, sem servidor — roda em GitHub Pages e offline.</a:t>
+              <a:t>Aplicação no ar: </a:t>
+            </a:r>
+            <a:pPr indent="0" marL="0">
+              <a:buNone/>
+            </a:pPr>
+            <a:r>
+              <a:rPr lang="en-US" sz="1050" b="1" dirty="0">
+                <a:solidFill>
+                  <a:srgbClr val="009B98"/>
+                </a:solidFill>
+                <a:latin typeface="Calibri" pitchFamily="34" charset="0"/>
+                <a:ea typeface="Calibri" pitchFamily="34" charset="-122"/>
+                <a:cs typeface="Calibri" pitchFamily="34" charset="-120"/>
+              </a:rPr>
+              <a:t>nelsondiniz-p.github.io/pulso-vital-analytics</a:t>
             </a:r>
             <a:endParaRPr lang="en-US" sz="1050" dirty="0"/>
           </a:p>
@@ -20680,7 +20694,21 @@
                 <a:ea typeface="Calibri" pitchFamily="34" charset="-122"/>
                 <a:cs typeface="Calibri" pitchFamily="34" charset="-120"/>
               </a:rPr>
-              <a:t>Aplicação navegável, sem servidor — roda em GitHub Pages e offline.</a:t>
+              <a:t>Aplicação no ar: </a:t>
+            </a:r>
+            <a:pPr indent="0" marL="0">
+              <a:buNone/>
+            </a:pPr>
+            <a:r>
+              <a:rPr lang="en-US" sz="1050" b="1" dirty="0">
+                <a:solidFill>
+                  <a:srgbClr val="009B98"/>
+                </a:solidFill>
+                <a:latin typeface="Calibri" pitchFamily="34" charset="0"/>
+                <a:ea typeface="Calibri" pitchFamily="34" charset="-122"/>
+                <a:cs typeface="Calibri" pitchFamily="34" charset="-120"/>
+              </a:rPr>
+              <a:t>nelsondiniz-p.github.io/pulso-vital-analytics</a:t>
             </a:r>
             <a:endParaRPr lang="en-US" sz="1050" dirty="0"/>
           </a:p>
@@ -21108,7 +21136,21 @@
                 <a:ea typeface="Calibri" pitchFamily="34" charset="-122"/>
                 <a:cs typeface="Calibri" pitchFamily="34" charset="-120"/>
               </a:rPr>
-              <a:t>Aplicação navegável, sem servidor — roda em GitHub Pages e offline.</a:t>
+              <a:t>Aplicação no ar: </a:t>
+            </a:r>
+            <a:pPr indent="0" marL="0">
+              <a:buNone/>
+            </a:pPr>
+            <a:r>
+              <a:rPr lang="en-US" sz="1050" b="1" dirty="0">
+                <a:solidFill>
+                  <a:srgbClr val="009B98"/>
+                </a:solidFill>
+                <a:latin typeface="Calibri" pitchFamily="34" charset="0"/>
+                <a:ea typeface="Calibri" pitchFamily="34" charset="-122"/>
+                <a:cs typeface="Calibri" pitchFamily="34" charset="-120"/>
+              </a:rPr>
+              <a:t>nelsondiniz-p.github.io/pulso-vital-analytics</a:t>
             </a:r>
             <a:endParaRPr lang="en-US" sz="1050" dirty="0"/>
           </a:p>

</xml_diff>

<commit_message>
Separa documentacao tecnica de material interno da equipe
O repositorio publico e o entregavel tecnico do projeto. Tres coisas nao
pertenciam a ele:

- docs/guia_oracle.md era um tutorial de criacao de conta na Oracle Cloud,
  escrito para a propria equipe. Reescrito como docs/implantacao_oracle.md,
  na voz do projeto: pre-requisitos, ordem de execucao dos scripts, validacao
  da carga e diagnostico da camada Select AI.
- docs/roteiro_video_pitch.md era o roteiro de fala da equipe, nao documentacao
  da solucao. Sai do repositorio e segue disponivel fora dele.
- As notas do apresentador do deck citavam pesos de avaliacao e traziam
  lembretes operacionais. Reescritas como orientacao de conteudo.

README e deck atualizados para a nova referencia.
</commit_message>
<xml_diff>
--- a/EC_Sprint_2_1TSCO_EvidenciasConstrucao_PULSO_VitalAnalytics.pptx
+++ b/EC_Sprint_2_1TSCO_EvidenciasConstrucao_PULSO_VitalAnalytics.pptx
@@ -877,7 +877,7 @@
           <a:p>
             <a:r>
               <a:rPr lang="en-US" dirty="0"/>
-              <a:t>Quarta entrega: modelos. Cada técnica existe para responder uma pergunta concreta de gestão, não para demonstrar ferramenta.</a:t>
+              <a:t>Cada técnica existe para responder uma pergunta concreta de gestão, não para demonstrar ferramenta.</a:t>
             </a:r>
             <a:endParaRPr lang="en-US" dirty="0"/>
           </a:p>
@@ -965,7 +965,7 @@
           <a:p>
             <a:r>
               <a:rPr lang="en-US" dirty="0"/>
-              <a:t>Ponto forte para a banca: sabemos que a métrica aponta para k=2 e escolhemos k=4 conscientemente, porque a métrica otimiza separação estatística, não utilidade de gestão.</a:t>
+              <a:t>A silhueta aponta para k=2, e escolhemos k=4 conscientemente: a métrica otimiza separação estatística, não utilidade de gestão. Com dois grupos a rede se divide apenas em cheia e vazia, o que não orienta nenhuma decisão.</a:t>
             </a:r>
             <a:endParaRPr lang="en-US" dirty="0"/>
           </a:p>
@@ -1053,7 +1053,7 @@
           <a:p>
             <a:r>
               <a:rPr lang="en-US" dirty="0"/>
-              <a:t>Se houver uma pergunta técnica da banca, é sobre isto. Mostra que entendemos o dado, não só a ferramenta.</a:t>
+              <a:t>Os dois casos mostram que o tratamento de dados é decisão analítica, não limpeza: em ambos, o resultado sem o ajuste apontaria para o município errado.</a:t>
             </a:r>
             <a:endParaRPr lang="en-US" dirty="0"/>
           </a:p>
@@ -1141,7 +1141,7 @@
           <a:p>
             <a:r>
               <a:rPr lang="en-US" dirty="0"/>
-              <a:t>Quinta entrega: evidências visuais. Declarar a limitação do indicador é parte da entrega — um MVP que esconde o limite é pior que um que o declara.</a:t>
+              <a:t>Declarar a limitação do indicador é parte da entrega — um MVP que esconde o limite é pior que um que o declara.</a:t>
             </a:r>
             <a:endParaRPr lang="en-US" dirty="0"/>
           </a:p>
@@ -1405,7 +1405,7 @@
           <a:p>
             <a:r>
               <a:rPr lang="en-US" dirty="0"/>
-              <a:t>ATENÇÃO: substituir o bloco de código por capturas de tela do ambiente Oracle assim que o Autonomous Database estiver provisionado. A captura mais importante é a do SELECT AI showsql — pergunta em português entrando, SQL saindo.</a:t>
+              <a:t>O object_list é a fronteira do que a IA enxerga, e os COMMENT ON do esquema são o que ensina o negócio a ela. É por isso que a modelagem de dados é o trabalho que faz o Select AI funcionar — não a chamada de API.</a:t>
             </a:r>
             <a:endParaRPr lang="en-US" dirty="0"/>
           </a:p>
@@ -1581,7 +1581,7 @@
           <a:p>
             <a:r>
               <a:rPr lang="en-US" dirty="0"/>
-              <a:t>ATENÇÃO: substituir &lt;usuario&gt; pelo endereço real do repositório antes de gerar o PDF e o vídeo.</a:t>
+              <a:t>O repositório é público e reúne todo o código gerado no projeto: extração, integração, modelos, scripts do Oracle, notebook de análise exploratória e a documentação de arquitetura e implantação.</a:t>
             </a:r>
             <a:endParaRPr lang="en-US" dirty="0"/>
           </a:p>
@@ -1669,7 +1669,7 @@
           <a:p>
             <a:r>
               <a:rPr lang="en-US" dirty="0"/>
-              <a:t>ATENÇÃO: inserir o link do YouTube neste slide antes da entrega. O mesmo link vai no arquivo link_video_pitch.txt, dentro do zip.</a:t>
+              <a:t>A estrutura do pitch segue os seis blocos sugeridos, com dois minutos reservados à demonstração ao vivo — que é onde a solução se prova.</a:t>
             </a:r>
             <a:endParaRPr lang="en-US" dirty="0"/>
           </a:p>
@@ -1757,7 +1757,7 @@
           <a:p>
             <a:r>
               <a:rPr lang="en-US" dirty="0"/>
-              <a:t>Oitava entrega: resultados. O ponto a enfatizar é que nenhum número aqui é ilustrativo — todos saem de fonte pública verificável.</a:t>
+              <a:t>O ponto a enfatizar é que nenhum número aqui é ilustrativo — todos saem de fonte pública verificável.</a:t>
             </a:r>
             <a:endParaRPr lang="en-US" dirty="0"/>
           </a:p>
@@ -2109,7 +2109,7 @@
           <a:p>
             <a:r>
               <a:rPr lang="en-US" dirty="0"/>
-              <a:t>Primeira entrega: documentação de gestão atualizada. O quadro mostra o que foi concluído, o que está em andamento e o que fica para a próxima evolução — nada foi removido do planejamento original.</a:t>
+              <a:t>O quadro mostra o que foi concluído, o que está em andamento e o que fica para a próxima evolução — nada foi removido do planejamento original.</a:t>
             </a:r>
             <a:endParaRPr lang="en-US" dirty="0"/>
           </a:p>
@@ -2197,7 +2197,7 @@
           <a:p>
             <a:r>
               <a:rPr lang="en-US" dirty="0"/>
-              <a:t>Segunda entrega: escopo. Fomos deliberadamente enxutos. O que não foi implementado está declarado como evolução planejada, não escondido.</a:t>
+              <a:t>Fomos deliberadamente enxutos no escopo. O que não foi implementado está declarado como evolução planejada, não escondido.</a:t>
             </a:r>
             <a:endParaRPr lang="en-US" dirty="0"/>
           </a:p>
@@ -2549,7 +2549,7 @@
           <a:p>
             <a:r>
               <a:rPr lang="en-US" dirty="0"/>
-              <a:t>Terceira entrega: arquitetura. Cinco camadas — origem, ingestão, armazenamento, modelagem e consumo. Cada fonte entra pelo mecanismo que a natureza dela pede.</a:t>
+              <a:t>Cinco camadas — origem, ingestão, armazenamento, modelagem e consumo. Cada fonte entra pelo mecanismo que a natureza dela pede.</a:t>
             </a:r>
             <a:endParaRPr lang="en-US" dirty="0"/>
           </a:p>
@@ -12840,7 +12840,7 @@
                 <a:ea typeface="Courier New" pitchFamily="34" charset="-122"/>
                 <a:cs typeface="Courier New" pitchFamily="34" charset="-120"/>
               </a:rPr>
-              <a:t>                        guia Oracle, evidências</a:t>
+              <a:t>                        implantação, evidências</a:t>
             </a:r>
             <a:endParaRPr lang="en-US" sz="950" dirty="0"/>
           </a:p>
@@ -13221,7 +13221,7 @@
                 <a:ea typeface="Courier New" pitchFamily="34" charset="-122"/>
                 <a:cs typeface="Courier New" pitchFamily="34" charset="-120"/>
               </a:rPr>
-              <a:t>docs/guia_oracle.md</a:t>
+              <a:t>docs/implantacao_oracle.md</a:t>
             </a:r>
             <a:endParaRPr lang="en-US" sz="1100" dirty="0"/>
           </a:p>
@@ -13260,7 +13260,7 @@
                 <a:ea typeface="Calibri" pitchFamily="34" charset="-122"/>
                 <a:cs typeface="Calibri" pitchFamily="34" charset="-120"/>
               </a:rPr>
-              <a:t>Provisionamento do Autonomous Database passo a passo, com solução para cada erro comum</a:t>
+              <a:t>Implantação da camada Oracle: ordem dos scripts, validação da carga e diagnóstico do Select AI</a:t>
             </a:r>
             <a:endParaRPr lang="en-US" sz="1050" dirty="0"/>
           </a:p>
@@ -14688,7 +14688,21 @@
                 <a:ea typeface="Calibri" pitchFamily="34" charset="-122"/>
                 <a:cs typeface="Calibri" pitchFamily="34" charset="-120"/>
               </a:rPr>
-              <a:t>Link do vídeo no YouTube:   (inserir antes da entrega)</a:t>
+              <a:t>Link do vídeo no YouTube:   </a:t>
+            </a:r>
+            <a:pPr indent="0" marL="0">
+              <a:buNone/>
+            </a:pPr>
+            <a:r>
+              <a:rPr lang="en-US" sz="1200" b="1" dirty="0">
+                <a:solidFill>
+                  <a:srgbClr val="D9452B"/>
+                </a:solidFill>
+                <a:latin typeface="Calibri" pitchFamily="34" charset="0"/>
+                <a:ea typeface="Calibri" pitchFamily="34" charset="-122"/>
+                <a:cs typeface="Calibri" pitchFamily="34" charset="-120"/>
+              </a:rPr>
+              <a:t>colar aqui antes de fechar a entrega</a:t>
             </a:r>
             <a:endParaRPr lang="en-US" sz="1200" dirty="0"/>
           </a:p>

</xml_diff>